<commit_message>
test(e2e): refresh fixtures stale since shape ids became per-slide
The committed decks predate the slide builder numbering shape ids per slide
(first id 2, not a deck-wide counter), so every e2e run regenerated them and
they showed as modified in git status. Generation is already byte-stable
(write-fixture.ts pins entry dates and skips identical writes), so committing
the current output ends the churn. ole-embed also picks up a regenerated
image1.png. 655 e2e specs that load these decks pass.

Co-Authored-By: Claude Sonnet 5 <noreply@anthropic.com>
</commit_message>
<xml_diff>
--- a/viewers/pptx/e2e/fixtures/cinematic-fragments.pptx
+++ b/viewers/pptx/e2e/fixtures/cinematic-fragments.pptx
@@ -526,7 +526,7 @@
       </p:grpSpPr>
       <p:sp>
         <p:nvSpPr>
-          <p:cNvPr id="3" name="TextBox 3"/>
+          <p:cNvPr id="2" name="TextBox 3"/>
           <p:cNvSpPr txBox="1"/>
           <p:nvPr/>
         </p:nvSpPr>
@@ -591,7 +591,7 @@
       </p:grpSpPr>
       <p:sp>
         <p:nvSpPr>
-          <p:cNvPr id="4" name="TextBox 4"/>
+          <p:cNvPr id="2" name="TextBox 4"/>
           <p:cNvSpPr txBox="1"/>
           <p:nvPr/>
         </p:nvSpPr>
@@ -656,7 +656,7 @@
       </p:grpSpPr>
       <p:sp>
         <p:nvSpPr>
-          <p:cNvPr id="5" name="TextBox 5"/>
+          <p:cNvPr id="2" name="TextBox 5"/>
           <p:cNvSpPr txBox="1"/>
           <p:nvPr/>
         </p:nvSpPr>
@@ -721,7 +721,7 @@
       </p:grpSpPr>
       <p:sp>
         <p:nvSpPr>
-          <p:cNvPr id="6" name="TextBox 6"/>
+          <p:cNvPr id="2" name="TextBox 6"/>
           <p:cNvSpPr txBox="1"/>
           <p:nvPr/>
         </p:nvSpPr>
@@ -786,7 +786,7 @@
       </p:grpSpPr>
       <p:sp>
         <p:nvSpPr>
-          <p:cNvPr id="7" name="TextBox 7"/>
+          <p:cNvPr id="2" name="TextBox 7"/>
           <p:cNvSpPr txBox="1"/>
           <p:nvPr/>
         </p:nvSpPr>
@@ -851,7 +851,7 @@
       </p:grpSpPr>
       <p:sp>
         <p:nvSpPr>
-          <p:cNvPr id="8" name="TextBox 8"/>
+          <p:cNvPr id="2" name="TextBox 8"/>
           <p:cNvSpPr txBox="1"/>
           <p:nvPr/>
         </p:nvSpPr>

</xml_diff>